<commit_message>
Jan 22 cover: keep compost on one line
Co-Authored-By: Claude Opus 5.5 <noreply@anthropic.com>
Claude-Session: https://claude.ai/code/session_019Ej1kT2Mv89M73b5H6uzho
</commit_message>
<xml_diff>
--- a/apps/web/public/wormhole/decks/22-01-2027-costa-rica-building-compost-v6.pptx
+++ b/apps/web/public/wormhole/decks/22-01-2027-costa-rica-building-compost-v6.pptx
@@ -3231,8 +3231,8 @@
         </p:nvSpPr>
         <p:spPr>
           <a:xfrm>
-            <a:off x="423333" y="1439333"/>
-            <a:ext cx="2540000" cy="3386667"/>
+            <a:off x="380000" y="1439333"/>
+            <a:ext cx="2950000" cy="3386667"/>
           </a:xfrm>
           <a:prstGeom prst="rect">
             <a:avLst/>

</xml_diff>